<commit_message>
Update IEC slide with Green Renuka Ji Fair 2025 data
Added 4th bullet for Green Renuka Ji Fair 2025 (3rd edition) and updated the highlight box with key impact stats: 10.2 MT dry waste collected, 5,550 kgs recycled, 99.4% compliance across 500 stalls.

https://claude.ai/code/session_01332dqa2KcWYYMDUJK9w2VB
</commit_message>
<xml_diff>
--- a/IEC_Initiatives_RenukaJi.pptx
+++ b/IEC_Initiatives_RenukaJi.pptx
@@ -3390,8 +3390,73 @@
         </p:nvSpPr>
         <p:spPr>
           <a:xfrm>
+            <a:off x="320040" y="4105656"/>
+            <a:ext cx="6858000" cy="868680"/>
+          </a:xfrm>
+          <a:prstGeom prst="roundRect">
+            <a:avLst>
+              <a:gd name="adj" fmla="val 5000"/>
+            </a:avLst>
+          </a:prstGeom>
+          <a:solidFill>
+            <a:srgbClr val="F5F0E6"/>
+          </a:solidFill>
+          <a:ln w="9525">
+            <a:solidFill>
+              <a:srgbClr val="D9C9A8"/>
+            </a:solidFill>
+          </a:ln>
+        </p:spPr>
+        <p:style>
+          <a:lnRef idx="1">
+            <a:schemeClr val="accent1"/>
+          </a:lnRef>
+          <a:fillRef idx="3">
+            <a:schemeClr val="accent1"/>
+          </a:fillRef>
+          <a:effectRef idx="2">
+            <a:schemeClr val="accent1"/>
+          </a:effectRef>
+          <a:fontRef idx="minor">
+            <a:schemeClr val="lt1"/>
+          </a:fontRef>
+        </p:style>
+        <p:txBody>
+          <a:bodyPr rtlCol="0" anchor="ctr" wrap="square" lIns="127000" rIns="101600" tIns="101600" bIns="50800"/>
+          <a:lstStyle/>
+          <a:p>
+            <a:pPr algn="l"/>
+            <a:r>
+              <a:rPr b="1" sz="1300">
+                <a:solidFill>
+                  <a:srgbClr val="1A1A1A"/>
+                </a:solidFill>
+                <a:latin typeface="Calibri"/>
+              </a:rPr>
+              <a:t>Green Renuka Ji Fair 2025</a:t>
+            </a:r>
+            <a:r>
+              <a:rPr b="0" sz="1200">
+                <a:solidFill>
+                  <a:srgbClr val="3A3A3A"/>
+                </a:solidFill>
+                <a:latin typeface="Calibri"/>
+              </a:rPr>
+              <a:t> 3rd edition — 10.2 MT dry waste collected, 5,550 kgs recycled across 500 stalls; compliance rate reached 99.4% by Day 3</a:t>
+            </a:r>
+          </a:p>
+        </p:txBody>
+      </p:sp>
+      <p:sp>
+        <p:nvSpPr>
+          <p:cNvPr id="8" name="Rounded Rectangle 7"/>
+          <p:cNvSpPr/>
+          <p:nvPr/>
+        </p:nvSpPr>
+        <p:spPr>
+          <a:xfrm>
             <a:off x="7452360" y="1005840"/>
-            <a:ext cx="4389120" cy="1920240"/>
+            <a:ext cx="4389120" cy="2926080"/>
           </a:xfrm>
           <a:prstGeom prst="roundRect">
             <a:avLst>
@@ -3425,20 +3490,106 @@
           <a:p>
             <a:pPr algn="l"/>
             <a:r>
-              <a:rPr b="0" sz="1200">
+              <a:rPr b="0" sz="1100">
                 <a:solidFill>
                   <a:srgbClr val="1A1A1A"/>
                 </a:solidFill>
                 <a:latin typeface="Calibri"/>
               </a:rPr>
-              <a:t>Panchayat engagement across Dadahu &amp; Khalakeyar Panchayats — resulting in a dedicated Waste Bank allocation to support the programme's collection and storage operations.</a:t>
-            </a:r>
-          </a:p>
-        </p:txBody>
-      </p:sp>
-      <p:sp>
-        <p:nvSpPr>
-          <p:cNvPr id="8" name="Rounded Rectangle 7"/>
+              <a:t>Panchayat engagement across Dadahu &amp; Khalakeyar Panchayats — resulting in a dedicated Waste Bank allocation.
+Green Renuka Ji Fair 2025 — Key Impact:
+</a:t>
+            </a:r>
+          </a:p>
+          <a:p>
+            <a:pPr algn="l"/>
+            <a:r>
+              <a:rPr b="1" sz="1300">
+                <a:solidFill>
+                  <a:srgbClr val="1A1A1A"/>
+                </a:solidFill>
+                <a:latin typeface="Calibri"/>
+              </a:rPr>
+              <a:t>10.2 MT  </a:t>
+            </a:r>
+            <a:r>
+              <a:rPr b="0" sz="1000">
+                <a:solidFill>
+                  <a:srgbClr val="3C2800"/>
+                </a:solidFill>
+                <a:latin typeface="Calibri"/>
+              </a:rPr>
+              <a:t>Dry Waste Collected</a:t>
+            </a:r>
+          </a:p>
+          <a:p>
+            <a:pPr algn="l"/>
+            <a:r>
+              <a:rPr b="1" sz="1300">
+                <a:solidFill>
+                  <a:srgbClr val="1A1A1A"/>
+                </a:solidFill>
+                <a:latin typeface="Calibri"/>
+              </a:rPr>
+              <a:t>5,550 kgs  </a:t>
+            </a:r>
+            <a:r>
+              <a:rPr b="0" sz="1000">
+                <a:solidFill>
+                  <a:srgbClr val="3C2800"/>
+                </a:solidFill>
+                <a:latin typeface="Calibri"/>
+              </a:rPr>
+              <a:t>Waste Recycled</a:t>
+            </a:r>
+          </a:p>
+          <a:p>
+            <a:pPr algn="l"/>
+            <a:r>
+              <a:rPr b="1" sz="1300">
+                <a:solidFill>
+                  <a:srgbClr val="1A1A1A"/>
+                </a:solidFill>
+                <a:latin typeface="Calibri"/>
+              </a:rPr>
+              <a:t>99.4%  </a:t>
+            </a:r>
+            <a:r>
+              <a:rPr b="0" sz="1000">
+                <a:solidFill>
+                  <a:srgbClr val="3C2800"/>
+                </a:solidFill>
+                <a:latin typeface="Calibri"/>
+              </a:rPr>
+              <a:t>Peak Compliance (Day 3)</a:t>
+            </a:r>
+          </a:p>
+          <a:p>
+            <a:pPr algn="l"/>
+            <a:r>
+              <a:rPr b="1" sz="1300">
+                <a:solidFill>
+                  <a:srgbClr val="1A1A1A"/>
+                </a:solidFill>
+                <a:latin typeface="Calibri"/>
+              </a:rPr>
+              <a:t>500 Stalls  </a:t>
+            </a:r>
+            <a:r>
+              <a:rPr b="0" sz="1000">
+                <a:solidFill>
+                  <a:srgbClr val="3C2800"/>
+                </a:solidFill>
+                <a:latin typeface="Calibri"/>
+              </a:rPr>
+              <a:t>Monitored at Fair</a:t>
+            </a:r>
+          </a:p>
+        </p:txBody>
+      </p:sp>
+      <p:sp>
+        <p:nvSpPr>
+          <p:cNvPr id="9" name="Rounded Rectangle 8"/>
           <p:cNvSpPr/>
           <p:nvPr/>
         </p:nvSpPr>
@@ -3494,7 +3645,7 @@
       </p:sp>
       <p:sp>
         <p:nvSpPr>
-          <p:cNvPr id="9" name="Rounded Rectangle 8"/>
+          <p:cNvPr id="10" name="Rounded Rectangle 9"/>
           <p:cNvSpPr/>
           <p:nvPr/>
         </p:nvSpPr>
@@ -3550,7 +3701,7 @@
       </p:sp>
       <p:sp>
         <p:nvSpPr>
-          <p:cNvPr id="10" name="Rounded Rectangle 9"/>
+          <p:cNvPr id="11" name="Rounded Rectangle 10"/>
           <p:cNvSpPr/>
           <p:nvPr/>
         </p:nvSpPr>

</xml_diff>